<commit_message>
Polish loop 1: product voice, display ids, evidence frames, S3 archive, VeloDB validation
- Backend: plain-English reasons, C-<order>-<hex> display ids, customer names, evidence frame
  thumbnails, mode labels, needs_info for unknown orders, Slack text with deep link
- Frontend: Demo data / Live status, Policy engine labels, evidence thumbnails, Open in Refund
  Desk deep link, needs_info card, toasts, skeletons, mobile top bar, a11y, Reset demo data
- AWS: optional S3 evidence archive on upload (verified against an S3-compatible store),
  CloudFormation for the evidence bucket + EC2 host (AgentX engine + live-stream relay)
- VeloDB: kit validated on Apache Doris 2.1 (schema, loader, 12 dashboard queries)
- Deck rebuilt with real screenshots; stage checklist; WorkBuddy skill routes aligned

Co-Authored-By: Claude Fable 5.1 <noreply@anthropic.com>
</commit_message>
<xml_diff>
--- a/docs/deck/ClaimSight-deck.pptx
+++ b/docs/deck/ClaimSight-deck.pptx
@@ -1127,7 +1127,7 @@
           <a:p>
             <a:r>
               <a:rPr lang="en-US" dirty="0"/>
-              <a:t>This is the wow beat. Say the number out loud: ninety-one percent similarity, different account, frozen, escalated, denied.</a:t>
+              <a:t>This is the wow beat. Say the number out loud: ninety-three percent similarity, different account, frozen, escalated, denied.</a:t>
             </a:r>
             <a:endParaRPr lang="en-US" dirty="0"/>
           </a:p>
@@ -5284,7 +5284,7 @@
                 <a:ea typeface="Arial" pitchFamily="34" charset="-122"/>
                 <a:cs typeface="Arial" pitchFamily="34" charset="-120"/>
               </a:rPr>
-              <a:t>Same footage from a different account. Image search finds it at 0.91 similarity. Claim frozen, escalated to Slack, denied by the manager in the Refund Desk.</a:t>
+              <a:t>Same footage from a different account. Image search finds it at 0.93 similarity. Claim frozen, escalated to Slack, denied by the manager in the Refund Desk.</a:t>
             </a:r>
             <a:endParaRPr lang="en-US" sz="1150" dirty="0"/>
           </a:p>
@@ -5814,7 +5814,7 @@
                 <a:ea typeface="Arial" pitchFamily="34" charset="-122"/>
                 <a:cs typeface="Arial" pitchFamily="34" charset="-120"/>
               </a:rPr>
-              <a:t>0.91</a:t>
+              <a:t>0.93</a:t>
             </a:r>
             <a:endParaRPr lang="en-US" sz="6400" dirty="0"/>
           </a:p>
@@ -7748,7 +7748,7 @@
                 <a:ea typeface="Arial" pitchFamily="34" charset="-122"/>
                 <a:cs typeface="Arial" pitchFamily="34" charset="-120"/>
               </a:rPr>
-              <a:t>Production plan: S3 evidence archive and EC2 for the AgentX self-host; the credits fund the first pilot.</a:t>
+              <a:t>S3 evidence archive on every upload (private, versioned, encrypted) and a CloudFormation stack for the EC2 host that runs AgentX and the live-evidence relay.</a:t>
             </a:r>
             <a:endParaRPr lang="en-US" sz="1150" dirty="0"/>
           </a:p>

</xml_diff>

<commit_message>
Docs, deck, stage materials and AWS host for the Damage Twin and Synthetic Evidence Lab
Co-Authored-By: Claude Fable 5.1 <noreply@anthropic.com>
</commit_message>
<xml_diff>
--- a/docs/deck/ClaimSight-deck.pptx
+++ b/docs/deck/ClaimSight-deck.pptx
@@ -3670,7 +3670,7 @@
                 <a:ea typeface="Arial" pitchFamily="34" charset="-122"/>
                 <a:cs typeface="Arial" pitchFamily="34" charset="-120"/>
               </a:rPr>
-              <a:t>Refund or replacement is written to the ledger by a cloud function that re-checks the limits itself. Humans are pulled in only above $75 or on a fraud signal.</a:t>
+              <a:t>Refund or replacement is written to the ledger by a cloud function that re-checks the limits itself. Humans are pulled in only above $75 or on a fraud signal. The receipt is a Blender-rendered 3D twin of the damage.</a:t>
             </a:r>
             <a:endParaRPr lang="en-US" sz="1300" dirty="0"/>
           </a:p>
@@ -3678,7 +3678,7 @@
       </p:sp>
       <p:pic>
         <p:nvPicPr>
-          <p:cNvPr id="16" name="Image 0" descr="/Users/moorthy/Downloads/Projects/Executable World- A Full Stack AI Hackathon &amp; Mixer/claimsight/assets/card.png">    </p:cNvPr>
+          <p:cNvPr id="16" name="Image 0" descr="/Users/moorthy/Downloads/Projects/Executable World- A Full Stack AI Hackathon &amp; Mixer/claimsight/assets/twin/sample-mug.png">    </p:cNvPr>
           <p:cNvPicPr>
             <a:picLocks noChangeAspect="1"/>
           </p:cNvPicPr>
@@ -3691,8 +3691,8 @@
         </p:blipFill>
         <p:spPr>
           <a:xfrm>
-            <a:off x="7040880" y="2011680"/>
-            <a:ext cx="4572000" cy="4114800"/>
+            <a:off x="6675120" y="2148840"/>
+            <a:ext cx="4937760" cy="3566160"/>
           </a:xfrm>
           <a:prstGeom prst="rect">
             <a:avLst/>
@@ -3702,6 +3702,45 @@
       <p:sp>
         <p:nvSpPr>
           <p:cNvPr id="17" name="Text 14"/>
+          <p:cNvSpPr txBox="1"/>
+          <p:nvPr/>
+        </p:nvSpPr>
+        <p:spPr>
+          <a:xfrm>
+            <a:off x="6675120" y="5760720"/>
+            <a:ext cx="4937760" cy="274320"/>
+          </a:xfrm>
+          <a:prstGeom prst="rect">
+            <a:avLst/>
+          </a:prstGeom>
+          <a:noFill/>
+          <a:ln/>
+        </p:spPr>
+        <p:txBody>
+          <a:bodyPr wrap="square" lIns="0" tIns="0" rIns="0" bIns="0" rtlCol="0" anchor="t"/>
+          <a:lstStyle/>
+          <a:p>
+            <a:pPr indent="0" marL="0">
+              <a:buNone/>
+            </a:pPr>
+            <a:r>
+              <a:rPr lang="en-US" sz="1000" dirty="0">
+                <a:solidFill>
+                  <a:srgbClr val="7F88A4"/>
+                </a:solidFill>
+                <a:latin typeface="Arial" pitchFamily="34" charset="0"/>
+                <a:ea typeface="Arial" pitchFamily="34" charset="-122"/>
+                <a:cs typeface="Arial" pitchFamily="34" charset="-120"/>
+              </a:rPr>
+              <a:t>Damage Twin receipt: rendered in Blender where Memories.ai saw the damage</a:t>
+            </a:r>
+            <a:endParaRPr lang="en-US" sz="1000" dirty="0"/>
+          </a:p>
+        </p:txBody>
+      </p:sp>
+      <p:sp>
+        <p:nvSpPr>
+          <p:cNvPr id="18" name="Text 15"/>
           <p:cNvSpPr txBox="1"/>
           <p:nvPr/>
         </p:nvSpPr>
@@ -3740,7 +3779,7 @@
       </p:sp>
       <p:sp>
         <p:nvSpPr>
-          <p:cNvPr id="18" name="Text 15"/>
+          <p:cNvPr id="19" name="Text 16"/>
           <p:cNvSpPr txBox="1"/>
           <p:nvPr/>
         </p:nvSpPr>
@@ -5137,7 +5176,7 @@
                 <a:ea typeface="Arial" pitchFamily="34" charset="-122"/>
                 <a:cs typeface="Arial" pitchFamily="34" charset="-120"/>
               </a:rPr>
-              <a:t>Damage seen at 0:03. Clauses P1, P2, P4 satisfied. $24 is under the $75 limit. Refund executed, transaction id on the card.</a:t>
+              <a:t>Damage seen at 0:02. Window checked (P1), damage visible (P2), replacement-first rule applied (P4). $24 is under the $75 limit: refund executed, transaction id on the card, and a 3D Damage Twin renders into the card 25 s later.</a:t>
             </a:r>
             <a:endParaRPr lang="en-US" sz="1150" dirty="0"/>
           </a:p>
@@ -5748,7 +5787,7 @@
         <p:spPr>
           <a:xfrm>
             <a:off x="548640" y="2103120"/>
-            <a:ext cx="5394960" cy="1005840"/>
+            <a:ext cx="5394960" cy="1097280"/>
           </a:xfrm>
           <a:prstGeom prst="rect">
             <a:avLst/>
@@ -5775,7 +5814,7 @@
                 <a:ea typeface="Arial" pitchFamily="34" charset="-122"/>
                 <a:cs typeface="Arial" pitchFamily="34" charset="-120"/>
               </a:rPr>
-              <a:t>Every evidence clip is indexed into the claims collection. Before paying, ClaimSight takes a frame from the new clip and runs an image search across every prior claim.</a:t>
+              <a:t>Every evidence clip is indexed into the claims collection. Before paying, ClaimSight takes a frame from the new clip and runs an image search across every prior claim. The detector was crash-tested with a Blender-rendered synthetic evidence set.</a:t>
             </a:r>
             <a:endParaRPr lang="en-US" sz="1500" dirty="0"/>
           </a:p>
@@ -5853,7 +5892,7 @@
                 <a:ea typeface="Arial" pitchFamily="34" charset="-122"/>
                 <a:cs typeface="Arial" pitchFamily="34" charset="-120"/>
               </a:rPr>
-              <a:t>similarity to claim C-1042, filed by another customer</a:t>
+              <a:t>similarity to the claim on order A1042, filed by another customer</a:t>
             </a:r>
             <a:endParaRPr lang="en-US" sz="1400" dirty="0"/>
           </a:p>
@@ -5953,11 +5992,11 @@
         <p:spPr>
           <a:xfrm>
             <a:off x="6309360" y="2011680"/>
-            <a:ext cx="5349240" cy="4160520"/>
+            <a:ext cx="5349240" cy="3246120"/>
           </a:xfrm>
           <a:prstGeom prst="roundRect">
             <a:avLst>
-              <a:gd name="adj" fmla="val 2637"/>
+              <a:gd name="adj" fmla="val 3380"/>
             </a:avLst>
           </a:prstGeom>
           <a:solidFill>
@@ -5987,7 +6026,7 @@
         <p:spPr>
           <a:xfrm>
             <a:off x="6400800" y="2103120"/>
-            <a:ext cx="5166360" cy="3977640"/>
+            <a:ext cx="5166360" cy="3063240"/>
           </a:xfrm>
           <a:prstGeom prst="rect">
             <a:avLst/>
@@ -5996,7 +6035,478 @@
       </p:pic>
       <p:sp>
         <p:nvSpPr>
-          <p:cNvPr id="10" name="Text 7"/>
+          <p:cNvPr id="10" name="Shape 7"/>
+          <p:cNvSpPr/>
+          <p:nvPr/>
+        </p:nvSpPr>
+        <p:spPr>
+          <a:xfrm>
+            <a:off x="6309360" y="5394960"/>
+            <a:ext cx="1234440" cy="868680"/>
+          </a:xfrm>
+          <a:prstGeom prst="roundRect">
+            <a:avLst>
+              <a:gd name="adj" fmla="val 12632"/>
+            </a:avLst>
+          </a:prstGeom>
+          <a:solidFill>
+            <a:srgbClr val="FFFFFF"/>
+          </a:solidFill>
+          <a:ln w="12700">
+            <a:solidFill>
+              <a:srgbClr val="DBE0EC"/>
+            </a:solidFill>
+            <a:prstDash val="solid"/>
+          </a:ln>
+        </p:spPr>
+      </p:sp>
+      <p:sp>
+        <p:nvSpPr>
+          <p:cNvPr id="11" name="Text 8"/>
+          <p:cNvSpPr txBox="1"/>
+          <p:nvPr/>
+        </p:nvSpPr>
+        <p:spPr>
+          <a:xfrm>
+            <a:off x="6419088" y="5468112"/>
+            <a:ext cx="1014984" cy="411480"/>
+          </a:xfrm>
+          <a:prstGeom prst="rect">
+            <a:avLst/>
+          </a:prstGeom>
+          <a:noFill/>
+          <a:ln/>
+        </p:spPr>
+        <p:txBody>
+          <a:bodyPr wrap="square" lIns="0" tIns="0" rIns="0" bIns="0" rtlCol="0" anchor="t"/>
+          <a:lstStyle/>
+          <a:p>
+            <a:pPr indent="0" marL="0">
+              <a:buNone/>
+            </a:pPr>
+            <a:r>
+              <a:rPr lang="en-US" sz="2200" b="1" dirty="0">
+                <a:solidFill>
+                  <a:srgbClr val="2A78D6"/>
+                </a:solidFill>
+                <a:latin typeface="Arial" pitchFamily="34" charset="0"/>
+                <a:ea typeface="Arial" pitchFamily="34" charset="-122"/>
+                <a:cs typeface="Arial" pitchFamily="34" charset="-120"/>
+              </a:rPr>
+              <a:t>—</a:t>
+            </a:r>
+            <a:endParaRPr lang="en-US" sz="2200" dirty="0"/>
+          </a:p>
+        </p:txBody>
+      </p:sp>
+      <p:sp>
+        <p:nvSpPr>
+          <p:cNvPr id="12" name="Text 9"/>
+          <p:cNvSpPr txBox="1"/>
+          <p:nvPr/>
+        </p:nvSpPr>
+        <p:spPr>
+          <a:xfrm>
+            <a:off x="6419088" y="5870448"/>
+            <a:ext cx="1014984" cy="365760"/>
+          </a:xfrm>
+          <a:prstGeom prst="rect">
+            <a:avLst/>
+          </a:prstGeom>
+          <a:noFill/>
+          <a:ln/>
+        </p:spPr>
+        <p:txBody>
+          <a:bodyPr wrap="square" lIns="0" tIns="0" rIns="0" bIns="0" rtlCol="0" anchor="t"/>
+          <a:lstStyle/>
+          <a:p>
+            <a:pPr indent="0" marL="0">
+              <a:lnSpc>
+                <a:spcPct val="105000"/>
+              </a:lnSpc>
+              <a:buNone/>
+            </a:pPr>
+            <a:r>
+              <a:rPr lang="en-US" sz="850" dirty="0">
+                <a:solidFill>
+                  <a:srgbClr val="4A5270"/>
+                </a:solidFill>
+                <a:latin typeface="Arial" pitchFamily="34" charset="0"/>
+                <a:ea typeface="Arial" pitchFamily="34" charset="-122"/>
+                <a:cs typeface="Arial" pitchFamily="34" charset="-120"/>
+              </a:rPr>
+              <a:t>synthetic clips rendered in Blender</a:t>
+            </a:r>
+            <a:endParaRPr lang="en-US" sz="850" dirty="0"/>
+          </a:p>
+        </p:txBody>
+      </p:sp>
+      <p:sp>
+        <p:nvSpPr>
+          <p:cNvPr id="13" name="Shape 10"/>
+          <p:cNvSpPr/>
+          <p:nvPr/>
+        </p:nvSpPr>
+        <p:spPr>
+          <a:xfrm>
+            <a:off x="7680960" y="5394960"/>
+            <a:ext cx="1234440" cy="868680"/>
+          </a:xfrm>
+          <a:prstGeom prst="roundRect">
+            <a:avLst>
+              <a:gd name="adj" fmla="val 12632"/>
+            </a:avLst>
+          </a:prstGeom>
+          <a:solidFill>
+            <a:srgbClr val="FFFFFF"/>
+          </a:solidFill>
+          <a:ln w="12700">
+            <a:solidFill>
+              <a:srgbClr val="DBE0EC"/>
+            </a:solidFill>
+            <a:prstDash val="solid"/>
+          </a:ln>
+        </p:spPr>
+      </p:sp>
+      <p:sp>
+        <p:nvSpPr>
+          <p:cNvPr id="14" name="Text 11"/>
+          <p:cNvSpPr txBox="1"/>
+          <p:nvPr/>
+        </p:nvSpPr>
+        <p:spPr>
+          <a:xfrm>
+            <a:off x="7790688" y="5468112"/>
+            <a:ext cx="1014984" cy="411480"/>
+          </a:xfrm>
+          <a:prstGeom prst="rect">
+            <a:avLst/>
+          </a:prstGeom>
+          <a:noFill/>
+          <a:ln/>
+        </p:spPr>
+        <p:txBody>
+          <a:bodyPr wrap="square" lIns="0" tIns="0" rIns="0" bIns="0" rtlCol="0" anchor="t"/>
+          <a:lstStyle/>
+          <a:p>
+            <a:pPr indent="0" marL="0">
+              <a:buNone/>
+            </a:pPr>
+            <a:r>
+              <a:rPr lang="en-US" sz="2200" b="1" dirty="0">
+                <a:solidFill>
+                  <a:srgbClr val="2A78D6"/>
+                </a:solidFill>
+                <a:latin typeface="Arial" pitchFamily="34" charset="0"/>
+                <a:ea typeface="Arial" pitchFamily="34" charset="-122"/>
+                <a:cs typeface="Arial" pitchFamily="34" charset="-120"/>
+              </a:rPr>
+              <a:t>—</a:t>
+            </a:r>
+            <a:endParaRPr lang="en-US" sz="2200" dirty="0"/>
+          </a:p>
+        </p:txBody>
+      </p:sp>
+      <p:sp>
+        <p:nvSpPr>
+          <p:cNvPr id="15" name="Text 12"/>
+          <p:cNvSpPr txBox="1"/>
+          <p:nvPr/>
+        </p:nvSpPr>
+        <p:spPr>
+          <a:xfrm>
+            <a:off x="7790688" y="5870448"/>
+            <a:ext cx="1014984" cy="365760"/>
+          </a:xfrm>
+          <a:prstGeom prst="rect">
+            <a:avLst/>
+          </a:prstGeom>
+          <a:noFill/>
+          <a:ln/>
+        </p:spPr>
+        <p:txBody>
+          <a:bodyPr wrap="square" lIns="0" tIns="0" rIns="0" bIns="0" rtlCol="0" anchor="t"/>
+          <a:lstStyle/>
+          <a:p>
+            <a:pPr indent="0" marL="0">
+              <a:lnSpc>
+                <a:spcPct val="105000"/>
+              </a:lnSpc>
+              <a:buNone/>
+            </a:pPr>
+            <a:r>
+              <a:rPr lang="en-US" sz="850" dirty="0">
+                <a:solidFill>
+                  <a:srgbClr val="4A5270"/>
+                </a:solidFill>
+                <a:latin typeface="Arial" pitchFamily="34" charset="0"/>
+                <a:ea typeface="Arial" pitchFamily="34" charset="-122"/>
+                <a:cs typeface="Arial" pitchFamily="34" charset="-120"/>
+              </a:rPr>
+              <a:t>twin recall at the shipped threshold</a:t>
+            </a:r>
+            <a:endParaRPr lang="en-US" sz="850" dirty="0"/>
+          </a:p>
+        </p:txBody>
+      </p:sp>
+      <p:sp>
+        <p:nvSpPr>
+          <p:cNvPr id="16" name="Shape 13"/>
+          <p:cNvSpPr/>
+          <p:nvPr/>
+        </p:nvSpPr>
+        <p:spPr>
+          <a:xfrm>
+            <a:off x="9052560" y="5394960"/>
+            <a:ext cx="1234440" cy="868680"/>
+          </a:xfrm>
+          <a:prstGeom prst="roundRect">
+            <a:avLst>
+              <a:gd name="adj" fmla="val 12632"/>
+            </a:avLst>
+          </a:prstGeom>
+          <a:solidFill>
+            <a:srgbClr val="FFFFFF"/>
+          </a:solidFill>
+          <a:ln w="12700">
+            <a:solidFill>
+              <a:srgbClr val="DBE0EC"/>
+            </a:solidFill>
+            <a:prstDash val="solid"/>
+          </a:ln>
+        </p:spPr>
+      </p:sp>
+      <p:sp>
+        <p:nvSpPr>
+          <p:cNvPr id="17" name="Text 14"/>
+          <p:cNvSpPr txBox="1"/>
+          <p:nvPr/>
+        </p:nvSpPr>
+        <p:spPr>
+          <a:xfrm>
+            <a:off x="9162288" y="5468112"/>
+            <a:ext cx="1014984" cy="411480"/>
+          </a:xfrm>
+          <a:prstGeom prst="rect">
+            <a:avLst/>
+          </a:prstGeom>
+          <a:noFill/>
+          <a:ln/>
+        </p:spPr>
+        <p:txBody>
+          <a:bodyPr wrap="square" lIns="0" tIns="0" rIns="0" bIns="0" rtlCol="0" anchor="t"/>
+          <a:lstStyle/>
+          <a:p>
+            <a:pPr indent="0" marL="0">
+              <a:buNone/>
+            </a:pPr>
+            <a:r>
+              <a:rPr lang="en-US" sz="2200" b="1" dirty="0">
+                <a:solidFill>
+                  <a:srgbClr val="2A78D6"/>
+                </a:solidFill>
+                <a:latin typeface="Arial" pitchFamily="34" charset="0"/>
+                <a:ea typeface="Arial" pitchFamily="34" charset="-122"/>
+                <a:cs typeface="Arial" pitchFamily="34" charset="-120"/>
+              </a:rPr>
+              <a:t>—</a:t>
+            </a:r>
+            <a:endParaRPr lang="en-US" sz="2200" dirty="0"/>
+          </a:p>
+        </p:txBody>
+      </p:sp>
+      <p:sp>
+        <p:nvSpPr>
+          <p:cNvPr id="18" name="Text 15"/>
+          <p:cNvSpPr txBox="1"/>
+          <p:nvPr/>
+        </p:nvSpPr>
+        <p:spPr>
+          <a:xfrm>
+            <a:off x="9162288" y="5870448"/>
+            <a:ext cx="1014984" cy="365760"/>
+          </a:xfrm>
+          <a:prstGeom prst="rect">
+            <a:avLst/>
+          </a:prstGeom>
+          <a:noFill/>
+          <a:ln/>
+        </p:spPr>
+        <p:txBody>
+          <a:bodyPr wrap="square" lIns="0" tIns="0" rIns="0" bIns="0" rtlCol="0" anchor="t"/>
+          <a:lstStyle/>
+          <a:p>
+            <a:pPr indent="0" marL="0">
+              <a:lnSpc>
+                <a:spcPct val="105000"/>
+              </a:lnSpc>
+              <a:buNone/>
+            </a:pPr>
+            <a:r>
+              <a:rPr lang="en-US" sz="850" dirty="0">
+                <a:solidFill>
+                  <a:srgbClr val="4A5270"/>
+                </a:solidFill>
+                <a:latin typeface="Arial" pitchFamily="34" charset="0"/>
+                <a:ea typeface="Arial" pitchFamily="34" charset="-122"/>
+                <a:cs typeface="Arial" pitchFamily="34" charset="-120"/>
+              </a:rPr>
+              <a:t>false-positive rate</a:t>
+            </a:r>
+            <a:endParaRPr lang="en-US" sz="850" dirty="0"/>
+          </a:p>
+        </p:txBody>
+      </p:sp>
+      <p:sp>
+        <p:nvSpPr>
+          <p:cNvPr id="19" name="Shape 16"/>
+          <p:cNvSpPr/>
+          <p:nvPr/>
+        </p:nvSpPr>
+        <p:spPr>
+          <a:xfrm>
+            <a:off x="10424160" y="5394960"/>
+            <a:ext cx="1234440" cy="868680"/>
+          </a:xfrm>
+          <a:prstGeom prst="roundRect">
+            <a:avLst>
+              <a:gd name="adj" fmla="val 12632"/>
+            </a:avLst>
+          </a:prstGeom>
+          <a:solidFill>
+            <a:srgbClr val="FFFFFF"/>
+          </a:solidFill>
+          <a:ln w="12700">
+            <a:solidFill>
+              <a:srgbClr val="DBE0EC"/>
+            </a:solidFill>
+            <a:prstDash val="solid"/>
+          </a:ln>
+        </p:spPr>
+      </p:sp>
+      <p:sp>
+        <p:nvSpPr>
+          <p:cNvPr id="20" name="Text 17"/>
+          <p:cNvSpPr txBox="1"/>
+          <p:nvPr/>
+        </p:nvSpPr>
+        <p:spPr>
+          <a:xfrm>
+            <a:off x="10533888" y="5468112"/>
+            <a:ext cx="1014984" cy="411480"/>
+          </a:xfrm>
+          <a:prstGeom prst="rect">
+            <a:avLst/>
+          </a:prstGeom>
+          <a:noFill/>
+          <a:ln/>
+        </p:spPr>
+        <p:txBody>
+          <a:bodyPr wrap="square" lIns="0" tIns="0" rIns="0" bIns="0" rtlCol="0" anchor="t"/>
+          <a:lstStyle/>
+          <a:p>
+            <a:pPr indent="0" marL="0">
+              <a:buNone/>
+            </a:pPr>
+            <a:r>
+              <a:rPr lang="en-US" sz="2200" b="1" dirty="0">
+                <a:solidFill>
+                  <a:srgbClr val="2A78D6"/>
+                </a:solidFill>
+                <a:latin typeface="Arial" pitchFamily="34" charset="0"/>
+                <a:ea typeface="Arial" pitchFamily="34" charset="-122"/>
+                <a:cs typeface="Arial" pitchFamily="34" charset="-120"/>
+              </a:rPr>
+              <a:t>—</a:t>
+            </a:r>
+            <a:endParaRPr lang="en-US" sz="2200" dirty="0"/>
+          </a:p>
+        </p:txBody>
+      </p:sp>
+      <p:sp>
+        <p:nvSpPr>
+          <p:cNvPr id="21" name="Text 18"/>
+          <p:cNvSpPr txBox="1"/>
+          <p:nvPr/>
+        </p:nvSpPr>
+        <p:spPr>
+          <a:xfrm>
+            <a:off x="10533888" y="5870448"/>
+            <a:ext cx="1014984" cy="365760"/>
+          </a:xfrm>
+          <a:prstGeom prst="rect">
+            <a:avLst/>
+          </a:prstGeom>
+          <a:noFill/>
+          <a:ln/>
+        </p:spPr>
+        <p:txBody>
+          <a:bodyPr wrap="square" lIns="0" tIns="0" rIns="0" bIns="0" rtlCol="0" anchor="t"/>
+          <a:lstStyle/>
+          <a:p>
+            <a:pPr indent="0" marL="0">
+              <a:lnSpc>
+                <a:spcPct val="105000"/>
+              </a:lnSpc>
+              <a:buNone/>
+            </a:pPr>
+            <a:r>
+              <a:rPr lang="en-US" sz="850" dirty="0">
+                <a:solidFill>
+                  <a:srgbClr val="4A5270"/>
+                </a:solidFill>
+                <a:latin typeface="Arial" pitchFamily="34" charset="0"/>
+                <a:ea typeface="Arial" pitchFamily="34" charset="-122"/>
+                <a:cs typeface="Arial" pitchFamily="34" charset="-120"/>
+              </a:rPr>
+              <a:t>similarity threshold from data</a:t>
+            </a:r>
+            <a:endParaRPr lang="en-US" sz="850" dirty="0"/>
+          </a:p>
+        </p:txBody>
+      </p:sp>
+      <p:sp>
+        <p:nvSpPr>
+          <p:cNvPr id="22" name="Text 19"/>
+          <p:cNvSpPr txBox="1"/>
+          <p:nvPr/>
+        </p:nvSpPr>
+        <p:spPr>
+          <a:xfrm>
+            <a:off x="6309360" y="5138928"/>
+            <a:ext cx="5349240" cy="228600"/>
+          </a:xfrm>
+          <a:prstGeom prst="rect">
+            <a:avLst/>
+          </a:prstGeom>
+          <a:noFill/>
+          <a:ln/>
+        </p:spPr>
+        <p:txBody>
+          <a:bodyPr wrap="square" lIns="0" tIns="0" rIns="0" bIns="0" rtlCol="0" anchor="t"/>
+          <a:lstStyle/>
+          <a:p>
+            <a:pPr indent="0" marL="0">
+              <a:buNone/>
+            </a:pPr>
+            <a:r>
+              <a:rPr lang="en-US" sz="900" dirty="0">
+                <a:solidFill>
+                  <a:srgbClr val="7F88A4"/>
+                </a:solidFill>
+                <a:latin typeface="Arial" pitchFamily="34" charset="0"/>
+                <a:ea typeface="Arial" pitchFamily="34" charset="-122"/>
+                <a:cs typeface="Arial" pitchFamily="34" charset="-120"/>
+              </a:rPr>
+              <a:t>Synthetic Evidence Lab · detector: Memories.ai image search</a:t>
+            </a:r>
+            <a:endParaRPr lang="en-US" sz="900" dirty="0"/>
+          </a:p>
+        </p:txBody>
+      </p:sp>
+      <p:sp>
+        <p:nvSpPr>
+          <p:cNvPr id="23" name="Text 20"/>
           <p:cNvSpPr txBox="1"/>
           <p:nvPr/>
         </p:nvSpPr>
@@ -6035,7 +6545,7 @@
       </p:sp>
       <p:sp>
         <p:nvSpPr>
-          <p:cNvPr id="11" name="Text 8"/>
+          <p:cNvPr id="24" name="Text 21"/>
           <p:cNvSpPr txBox="1"/>
           <p:nvPr/>
         </p:nvSpPr>

</xml_diff>

<commit_message>
Deck: lab metrics and twin render
</commit_message>
<xml_diff>
--- a/docs/deck/ClaimSight-deck.pptx
+++ b/docs/deck/ClaimSight-deck.pptx
@@ -5358,7 +5358,7 @@
       </p:sp>
       <p:pic>
         <p:nvPicPr>
-          <p:cNvPr id="17" name="Image 0" descr="/Users/moorthy/Downloads/Projects/Executable World- A Full Stack AI Hackathon &amp; Mixer/claimsight/public/screenshots/chat.png">    </p:cNvPr>
+          <p:cNvPr id="17" name="Image 0" descr="/Users/moorthy/Downloads/Projects/Executable World- A Full Stack AI Hackathon &amp; Mixer/claimsight/public/screenshots/chat-twin.png">    </p:cNvPr>
           <p:cNvPicPr>
             <a:picLocks noChangeAspect="1"/>
           </p:cNvPicPr>
@@ -6012,7 +6012,7 @@
       </p:sp>
       <p:pic>
         <p:nvPicPr>
-          <p:cNvPr id="9" name="Image 0" descr="/Users/moorthy/Downloads/Projects/Executable World- A Full Stack AI Hackathon &amp; Mixer/claimsight/public/screenshots/desk.png">    </p:cNvPr>
+          <p:cNvPr id="9" name="Image 0" descr="/Users/moorthy/Downloads/Projects/Executable World- A Full Stack AI Hackathon &amp; Mixer/claimsight/public/screenshots/lab.png">    </p:cNvPr>
           <p:cNvPicPr>
             <a:picLocks noChangeAspect="1"/>
           </p:cNvPicPr>
@@ -6093,7 +6093,7 @@
                 <a:ea typeface="Arial" pitchFamily="34" charset="-122"/>
                 <a:cs typeface="Arial" pitchFamily="34" charset="-120"/>
               </a:rPr>
-              <a:t>—</a:t>
+              <a:t>12</a:t>
             </a:r>
             <a:endParaRPr lang="en-US" sz="2200" dirty="0"/>
           </a:p>
@@ -6201,7 +6201,7 @@
                 <a:ea typeface="Arial" pitchFamily="34" charset="-122"/>
                 <a:cs typeface="Arial" pitchFamily="34" charset="-120"/>
               </a:rPr>
-              <a:t>—</a:t>
+              <a:t>75%</a:t>
             </a:r>
             <a:endParaRPr lang="en-US" sz="2200" dirty="0"/>
           </a:p>
@@ -6309,7 +6309,7 @@
                 <a:ea typeface="Arial" pitchFamily="34" charset="-122"/>
                 <a:cs typeface="Arial" pitchFamily="34" charset="-120"/>
               </a:rPr>
-              <a:t>—</a:t>
+              <a:t>18%</a:t>
             </a:r>
             <a:endParaRPr lang="en-US" sz="2200" dirty="0"/>
           </a:p>
@@ -6417,7 +6417,7 @@
                 <a:ea typeface="Arial" pitchFamily="34" charset="-122"/>
                 <a:cs typeface="Arial" pitchFamily="34" charset="-120"/>
               </a:rPr>
-              <a:t>—</a:t>
+              <a:t>0.76</a:t>
             </a:r>
             <a:endParaRPr lang="en-US" sz="2200" dirty="0"/>
           </a:p>
@@ -6498,7 +6498,7 @@
                 <a:ea typeface="Arial" pitchFamily="34" charset="-122"/>
                 <a:cs typeface="Arial" pitchFamily="34" charset="-120"/>
               </a:rPr>
-              <a:t>Synthetic Evidence Lab · detector: Memories.ai image search</a:t>
+              <a:t>Synthetic Evidence Lab · detector: local-baseline</a:t>
             </a:r>
             <a:endParaRPr lang="en-US" sz="900" dirty="0"/>
           </a:p>

</xml_diff>

<commit_message>
Judge-day re-weighting: product copy without vendor names, storyboard for the judges present, deck text, captioned backup video
Co-Authored-By: Claude Fable 5.1 <noreply@anthropic.com>
</commit_message>
<xml_diff>
--- a/docs/deck/ClaimSight-deck.pptx
+++ b/docs/deck/ClaimSight-deck.pptx
@@ -1127,7 +1127,7 @@
           <a:p>
             <a:r>
               <a:rPr lang="en-US" dirty="0"/>
-              <a:t>This is the wow beat. Say the number out loud: ninety-three percent similarity, different account, frozen, escalated, denied.</a:t>
+              <a:t>This is the wow beat. Say the number out loud: ninety-three percent similarity, different account, frozen, escalated, denied. If asked about Memories.ai: the pipeline is built against their API; no credits on the day, so canned evidence in the demo.</a:t>
             </a:r>
             <a:endParaRPr lang="en-US" dirty="0"/>
           </a:p>
@@ -3732,7 +3732,7 @@
                 <a:ea typeface="Arial" pitchFamily="34" charset="-122"/>
                 <a:cs typeface="Arial" pitchFamily="34" charset="-120"/>
               </a:rPr>
-              <a:t>Damage Twin receipt: rendered in Blender where Memories.ai saw the damage</a:t>
+              <a:t>Damage Twin receipt: rendered in Blender where the evidence showed the damage</a:t>
             </a:r>
             <a:endParaRPr lang="en-US" sz="1000" dirty="0"/>
           </a:p>
@@ -4214,7 +4214,7 @@
                 <a:ea typeface="Arial" pitchFamily="34" charset="-122"/>
                 <a:cs typeface="Arial" pitchFamily="34" charset="-120"/>
               </a:rPr>
-              <a:t>Memories.ai captions the clip and image-searches every prior claim for a twin.</a:t>
+              <a:t>The clip is captioned and its frames are searched against every prior claim for a twin.</a:t>
             </a:r>
             <a:endParaRPr lang="en-US" sz="1250" dirty="0"/>
           </a:p>
@@ -5323,7 +5323,7 @@
                 <a:ea typeface="Arial" pitchFamily="34" charset="-122"/>
                 <a:cs typeface="Arial" pitchFamily="34" charset="-120"/>
               </a:rPr>
-              <a:t>Same footage from a different account. Image search finds it at 0.93 similarity. Claim frozen, escalated to Slack, denied by the manager in the Refund Desk.</a:t>
+              <a:t>Same footage from a different account: matched at 0.93 similarity across prior claims. Claim frozen, escalated to Slack, denied by the manager in the Refund Desk.</a:t>
             </a:r>
             <a:endParaRPr lang="en-US" sz="1150" dirty="0"/>
           </a:p>
@@ -5814,7 +5814,7 @@
                 <a:ea typeface="Arial" pitchFamily="34" charset="-122"/>
                 <a:cs typeface="Arial" pitchFamily="34" charset="-120"/>
               </a:rPr>
-              <a:t>Every evidence clip is indexed into the claims collection. Before paying, ClaimSight takes a frame from the new clip and runs an image search across every prior claim. The detector was crash-tested with a Blender-rendered synthetic evidence set.</a:t>
+              <a:t>Every evidence clip is indexed. Before paying, ClaimSight takes a frame from the new clip and searches every prior claim for the same footage. The detector was crash-tested with a Blender-rendered synthetic evidence set.</a:t>
             </a:r>
             <a:endParaRPr lang="en-US" sz="1500" dirty="0"/>
           </a:p>
@@ -7826,7 +7826,7 @@
                 <a:ea typeface="Arial" pitchFamily="34" charset="-122"/>
                 <a:cs typeface="Arial" pitchFamily="34" charset="-120"/>
               </a:rPr>
-              <a:t>Video Datalake: upload, index, summary and captions, frame extraction, image search across the claims collection for the fraud twin.</a:t>
+              <a:t>Video Datalake client: upload, index, captions, frames, image search across prior claims. Built and contract-tested; demo day ran on canned evidence.</a:t>
             </a:r>
             <a:endParaRPr lang="en-US" sz="1150" dirty="0"/>
           </a:p>

</xml_diff>